<commit_message>
feat: add speaker notes removal tool and update pitch deck
Add `remove_speaker_notes.py` script to generate a notes-free version of
the pitch deck. Update pitch README with new variant documentation and
fix codebase path references. Update web favicons and add Image component
to navbar with favicon display.
</commit_message>
<xml_diff>
--- a/pitch/AgentVouch_walkthrough.pptx
+++ b/pitch/AgentVouch_walkthrough.pptx
@@ -20336,7 +20336,7 @@
 </file>
 
 <file path=ppt/slides/slide1.xml><?xml version="1.0" encoding="utf-8"?>
-<p:sld xmlns:a="http://schemas.openxmlformats.org/drawingml/2006/main" xmlns:r="http://schemas.openxmlformats.org/officeDocument/2006/relationships" xmlns:mc="http://schemas.openxmlformats.org/markup-compatibility/2006" xmlns:mv="urn:schemas-microsoft-com:mac:vml" xmlns:p="http://schemas.openxmlformats.org/presentationml/2006/main" xmlns:c="http://schemas.openxmlformats.org/drawingml/2006/chart" xmlns:dgm="http://schemas.openxmlformats.org/drawingml/2006/diagram" xmlns:o="urn:schemas-microsoft-com:office:office" xmlns:v="urn:schemas-microsoft-com:vml" xmlns:pvml="urn:schemas-microsoft-com:office:powerpoint" xmlns:com="http://schemas.openxmlformats.org/drawingml/2006/compatibility" xmlns:p14="http://schemas.microsoft.com/office/powerpoint/2010/main" xmlns:p15="http://schemas.microsoft.com/office/powerpoint/2012/main" xmlns:ahyp="http://schemas.microsoft.com/office/drawing/2018/hyperlinkcolor">
+<p:sld xmlns:a="http://schemas.openxmlformats.org/drawingml/2006/main" xmlns:p="http://schemas.openxmlformats.org/presentationml/2006/main" xmlns:r="http://schemas.openxmlformats.org/officeDocument/2006/relationships">
   <p:cSld>
     <p:bg>
       <p:bgPr>
@@ -20668,7 +20668,7 @@
                 <a:cs typeface="Inconsolata"/>
                 <a:sym typeface="Inconsolata"/>
               </a:rPr>
-              <a:t>Skills Marketplace  ·  Stake-based Vouching  ·  Programmable Trust</a:t>
+              <a:t>Skills Marketplace  ·  USDC-backed Vouching  ·  Programmable Trust</a:t>
             </a:r>
             <a:endParaRPr b="0" i="0" sz="1300" u="none" cap="none" strike="noStrike">
               <a:solidFill>
@@ -20737,7 +20737,7 @@
                 <a:cs typeface="Inconsolata"/>
                 <a:sym typeface="Inconsolata"/>
               </a:rPr>
-              <a:t>Colosseum Agent Hackathon  ·  Built for agents and people  ·  Solana Devnet</a:t>
+              <a:t>USDC-native v0.2.0  ·  Built for agents and people  ·  Solana Devnet</a:t>
             </a:r>
             <a:endParaRPr b="0" i="0" sz="1100" u="none" cap="none" strike="noStrike">
               <a:solidFill>
@@ -20986,7 +20986,7 @@
 </file>
 
 <file path=ppt/slides/slide10.xml><?xml version="1.0" encoding="utf-8"?>
-<p:sld xmlns:a="http://schemas.openxmlformats.org/drawingml/2006/main" xmlns:r="http://schemas.openxmlformats.org/officeDocument/2006/relationships" xmlns:mc="http://schemas.openxmlformats.org/markup-compatibility/2006" xmlns:mv="urn:schemas-microsoft-com:mac:vml" xmlns:p="http://schemas.openxmlformats.org/presentationml/2006/main" xmlns:c="http://schemas.openxmlformats.org/drawingml/2006/chart" xmlns:dgm="http://schemas.openxmlformats.org/drawingml/2006/diagram" xmlns:o="urn:schemas-microsoft-com:office:office" xmlns:v="urn:schemas-microsoft-com:vml" xmlns:pvml="urn:schemas-microsoft-com:office:powerpoint" xmlns:com="http://schemas.openxmlformats.org/drawingml/2006/compatibility" xmlns:p14="http://schemas.microsoft.com/office/powerpoint/2010/main" xmlns:p15="http://schemas.microsoft.com/office/powerpoint/2012/main" xmlns:ahyp="http://schemas.microsoft.com/office/drawing/2018/hyperlinkcolor">
+<p:sld xmlns:a="http://schemas.openxmlformats.org/drawingml/2006/main" xmlns:p="http://schemas.openxmlformats.org/presentationml/2006/main" xmlns:r="http://schemas.openxmlformats.org/officeDocument/2006/relationships">
   <p:cSld>
     <p:bg>
       <p:bgPr>
@@ -21254,7 +21254,7 @@
                 <a:cs typeface="Calibri"/>
                 <a:sym typeface="Calibri"/>
               </a:rPr>
-              <a:t>Two dispute paths — both backed by real economic consequences</a:t>
+              <a:t>Reports are skill-linked and backed by real economic consequences</a:t>
             </a:r>
             <a:endParaRPr b="0" i="0" sz="1400" u="none" cap="none" strike="noStrike">
               <a:solidFill>
@@ -21472,7 +21472,7 @@
                 <a:cs typeface="Inconsolata"/>
                 <a:sym typeface="Inconsolata"/>
               </a:rPr>
-              <a:t>Vouch</a:t>
+              <a:t>Free Skill</a:t>
             </a:r>
             <a:endParaRPr b="0" i="0" sz="1600" u="none" cap="none" strike="noStrike">
               <a:solidFill>
@@ -21578,7 +21578,7 @@
                 <a:cs typeface="Calibri"/>
                 <a:sym typeface="Calibri"/>
               </a:rPr>
-              <a:t>Challenger targets author citing malicious skill. Upheld: voucher stake slashed to challenger + bond returned. Vouch marked Slashed.</a:t>
+              <a:t>Challenger targets an author citing a bad free listing. Upheld: AuthorBond is first-loss capital; backing vouches are snapshot-linked for transparency.</a:t>
             </a:r>
             <a:endParaRPr b="0" i="0" sz="1200" u="none" cap="none" strike="noStrike">
               <a:solidFill>
@@ -21796,7 +21796,7 @@
                 <a:cs typeface="Inconsolata"/>
                 <a:sym typeface="Inconsolata"/>
               </a:rPr>
-              <a:t>Author</a:t>
+              <a:t>Paid Skill</a:t>
             </a:r>
             <a:endParaRPr b="0" i="0" sz="1600" u="none" cap="none" strike="noStrike">
               <a:solidFill>
@@ -21902,7 +21902,7 @@
                 <a:cs typeface="Calibri"/>
                 <a:sym typeface="Calibri"/>
               </a:rPr>
-              <a:t>Targets full author backing set atomically. AuthorBond slashed first, then backing vouchers proportionally. Upheld: bond returned to challenger.</a:t>
+              <a:t>Paid-skill disputes use AuthorBond first, then eligible linked backing vouchers according to stored liability scope.</a:t>
             </a:r>
             <a:endParaRPr b="0" i="0" sz="1200" u="none" cap="none" strike="noStrike">
               <a:solidFill>
@@ -22199,7 +22199,7 @@
                 <a:cs typeface="Calibri"/>
                 <a:sym typeface="Calibri"/>
               </a:rPr>
-              <a:t>Authors self-stake SOL as first-loss capital. Free-skill disputes: AuthorBond only. Paid-skill: AuthorBond then vouchers.</a:t>
+              <a:t>Authors post USDC AuthorBond as first-loss capital. Free listings require the configured bond floor.</a:t>
             </a:r>
             <a:endParaRPr b="0" i="0" sz="1200" u="none" cap="none" strike="noStrike">
               <a:solidFill>
@@ -22265,7 +22265,7 @@
                 <a:cs typeface="Calibri"/>
                 <a:sym typeface="Calibri"/>
               </a:rPr>
-              <a:t>Admin resolves disputes today  ·  Multi-sig / DAO governance on the roadmap</a:t>
+              <a:t>Authorized resolver today  ·  Multi-sig / DAO governance is a mainnet-readiness item</a:t>
             </a:r>
             <a:endParaRPr b="0" i="0" sz="1100" u="none" cap="none" strike="noStrike">
               <a:solidFill>
@@ -22447,7 +22447,7 @@
 </file>
 
 <file path=ppt/slides/slide11.xml><?xml version="1.0" encoding="utf-8"?>
-<p:sld xmlns:a="http://schemas.openxmlformats.org/drawingml/2006/main" xmlns:r="http://schemas.openxmlformats.org/officeDocument/2006/relationships" xmlns:mc="http://schemas.openxmlformats.org/markup-compatibility/2006" xmlns:mv="urn:schemas-microsoft-com:mac:vml" xmlns:p="http://schemas.openxmlformats.org/presentationml/2006/main" xmlns:c="http://schemas.openxmlformats.org/drawingml/2006/chart" xmlns:dgm="http://schemas.openxmlformats.org/drawingml/2006/diagram" xmlns:o="urn:schemas-microsoft-com:office:office" xmlns:v="urn:schemas-microsoft-com:vml" xmlns:pvml="urn:schemas-microsoft-com:office:powerpoint" xmlns:com="http://schemas.openxmlformats.org/drawingml/2006/compatibility" xmlns:p14="http://schemas.microsoft.com/office/powerpoint/2010/main" xmlns:p15="http://schemas.microsoft.com/office/powerpoint/2012/main" xmlns:ahyp="http://schemas.microsoft.com/office/drawing/2018/hyperlinkcolor">
+<p:sld xmlns:a="http://schemas.openxmlformats.org/drawingml/2006/main" xmlns:p="http://schemas.openxmlformats.org/presentationml/2006/main" xmlns:r="http://schemas.openxmlformats.org/officeDocument/2006/relationships">
   <p:cSld>
     <p:bg>
       <p:bgPr>
@@ -22781,7 +22781,7 @@
                 <a:cs typeface="Calibri"/>
                 <a:sym typeface="Calibri"/>
               </a:rPr>
-              <a:t>On-chain reputation — register, vouch, revoke, dispute, resolve</a:t>
+              <a:t>USDC-native reputation — register, bond, vouch, revoke, dispute, resolve</a:t>
             </a:r>
             <a:endParaRPr b="0" i="0" sz="1200" u="none" cap="none" strike="noStrike">
               <a:solidFill>
@@ -22977,7 +22977,7 @@
                 <a:cs typeface="Consolas"/>
                 <a:sym typeface="Consolas"/>
               </a:rPr>
-              <a:t>Skill marketplace — list, purchase, claim revenue</a:t>
+              <a:t>Skill marketplace — list, purchase, claim USDC rewards</a:t>
             </a:r>
             <a:endParaRPr b="0" i="0" sz="900" u="none" cap="none" strike="noStrike">
               <a:solidFill>
@@ -23097,7 +23097,7 @@
                 <a:cs typeface="Consolas"/>
                 <a:sym typeface="Consolas"/>
               </a:rPr>
-              <a:t>x402 payment flow — agents buy skills natively</a:t>
+              <a:t>Repo-backed x402 USDC flow — agents buy raw skills natively</a:t>
             </a:r>
             <a:endParaRPr b="0" i="0" sz="900" u="none" cap="none" strike="noStrike">
               <a:solidFill>
@@ -23675,7 +23675,7 @@
                 <a:cs typeface="Calibri"/>
                 <a:sym typeface="Calibri"/>
               </a:rPr>
-              <a:t>Marketplace payout escrow (author proceeds PDA)</a:t>
+              <a:t>Milestone 13: escrowed proceeds + purchaser refunds (WIP)</a:t>
             </a:r>
             <a:endParaRPr b="0" i="0" sz="1100" u="none" cap="none" strike="noStrike">
               <a:solidFill>
@@ -23800,7 +23800,7 @@
                 <a:cs typeface="Calibri"/>
                 <a:sym typeface="Calibri"/>
               </a:rPr>
-              <a:t>Multi-sig / DAO / A</a:t>
+              <a:t>Multi-sig / DAO / Agent DON dispute governance</a:t>
             </a:r>
             <a:r>
               <a:rPr lang="en" sz="1100">
@@ -23812,7 +23812,7 @@
                 <a:cs typeface="Calibri"/>
                 <a:sym typeface="Calibri"/>
               </a:rPr>
-              <a:t>gent DON</a:t>
+              <a:t/>
             </a:r>
             <a:r>
               <a:rPr b="0" i="0" lang="en" sz="1100" u="none" cap="none" strike="noStrike">
@@ -23824,7 +23824,7 @@
                 <a:cs typeface="Calibri"/>
                 <a:sym typeface="Calibri"/>
               </a:rPr>
-              <a:t> dispute governance</a:t>
+              <a:t/>
             </a:r>
             <a:endParaRPr b="0" i="0" sz="1100" u="none" cap="none" strike="noStrike">
               <a:solidFill>
@@ -23949,7 +23949,7 @@
                 <a:cs typeface="Calibri"/>
                 <a:sym typeface="Calibri"/>
               </a:rPr>
-              <a:t>USDC as native stake</a:t>
+              <a:t>SEO + LLM-facing docs</a:t>
             </a:r>
             <a:r>
               <a:rPr b="0" i="0" lang="en" sz="1100" u="none" cap="none" strike="noStrike">
@@ -23961,7 +23961,7 @@
                 <a:cs typeface="Calibri"/>
                 <a:sym typeface="Calibri"/>
               </a:rPr>
-              <a:t> / payment </a:t>
+              <a:t> refreshed in Milestone 14; </a:t>
             </a:r>
             <a:r>
               <a:rPr lang="en" sz="1100">
@@ -23973,7 +23973,7 @@
                 <a:cs typeface="Calibri"/>
                 <a:sym typeface="Calibri"/>
               </a:rPr>
-              <a:t>-</a:t>
+              <a:t>deck alignment </a:t>
             </a:r>
             <a:r>
               <a:rPr b="0" i="0" lang="en" sz="1100" u="none" cap="none" strike="noStrike">
@@ -23985,7 +23985,7 @@
                 <a:cs typeface="Calibri"/>
                 <a:sym typeface="Calibri"/>
               </a:rPr>
-              <a:t> deferred to v2</a:t>
+              <a:t>is Milestone 15</a:t>
             </a:r>
             <a:endParaRPr b="0" i="0" sz="1100" u="none" cap="none" strike="noStrike">
               <a:solidFill>
@@ -24235,7 +24235,7 @@
                 <a:cs typeface="Inconsolata"/>
                 <a:sym typeface="Inconsolata"/>
               </a:rPr>
-              <a:t>Program: ELmVnLSNuwNca4PfPqeqNowoUF8aDdtfto3rF9d89wf  •  Deployed: Solana Devnet</a:t>
+              <a:t>Program: AgNtCcWfeMYUzHxvGdZP5BJszQhx6NJGB4pQ7AN6XVWz  •  Deployed: Solana Devnet</a:t>
             </a:r>
             <a:endParaRPr b="0" i="0" sz="1100" u="none" cap="none" strike="noStrike">
               <a:solidFill>
@@ -24418,7 +24418,7 @@
 </file>
 
 <file path=ppt/slides/slide12.xml><?xml version="1.0" encoding="utf-8"?>
-<p:sld xmlns:a="http://schemas.openxmlformats.org/drawingml/2006/main" xmlns:r="http://schemas.openxmlformats.org/officeDocument/2006/relationships" xmlns:mc="http://schemas.openxmlformats.org/markup-compatibility/2006" xmlns:mv="urn:schemas-microsoft-com:mac:vml" xmlns:p="http://schemas.openxmlformats.org/presentationml/2006/main" xmlns:c="http://schemas.openxmlformats.org/drawingml/2006/chart" xmlns:dgm="http://schemas.openxmlformats.org/drawingml/2006/diagram" xmlns:o="urn:schemas-microsoft-com:office:office" xmlns:v="urn:schemas-microsoft-com:vml" xmlns:pvml="urn:schemas-microsoft-com:office:powerpoint" xmlns:com="http://schemas.openxmlformats.org/drawingml/2006/compatibility" xmlns:p14="http://schemas.microsoft.com/office/powerpoint/2010/main" xmlns:p15="http://schemas.microsoft.com/office/powerpoint/2012/main" xmlns:ahyp="http://schemas.microsoft.com/office/drawing/2018/hyperlinkcolor">
+<p:sld xmlns:a="http://schemas.openxmlformats.org/drawingml/2006/main" xmlns:p="http://schemas.openxmlformats.org/presentationml/2006/main" xmlns:r="http://schemas.openxmlformats.org/officeDocument/2006/relationships">
   <p:cSld>
     <p:bg>
       <p:bgPr>
@@ -24686,7 +24686,7 @@
                 <a:cs typeface="Inconsolata"/>
                 <a:sym typeface="Inconsolata"/>
               </a:rPr>
-              <a:t>Watch an agent get </a:t>
+              <a:t>Watch an agent </a:t>
             </a:r>
             <a:r>
               <a:rPr lang="en" sz="1500">
@@ -24698,7 +24698,7 @@
                 <a:cs typeface="Inconsolata"/>
                 <a:sym typeface="Inconsolata"/>
               </a:rPr>
-              <a:t>find a skill and install it, publish a skill, vouch for another agent, and file a challenge</a:t>
+              <a:t>find a skill and install it, publish a skill, vouch with USDC, and file a report</a:t>
             </a:r>
             <a:endParaRPr i="0" sz="1500" u="none" cap="none" strike="noStrike">
               <a:solidFill>
@@ -25146,7 +25146,7 @@
                 <a:cs typeface="Calibri"/>
                 <a:sym typeface="Calibri"/>
               </a:rPr>
-              <a:t>Vouch for an author with devnet SOL</a:t>
+              <a:t>Vouch for an author with devnet USDC</a:t>
             </a:r>
             <a:endParaRPr b="0" i="0" sz="1100" u="none" cap="none" strike="noStrike">
               <a:solidFill>
@@ -25317,7 +25317,7 @@
                 <a:cs typeface="Inconsolata"/>
                 <a:sym typeface="Inconsolata"/>
               </a:rPr>
-              <a:t>Challenge</a:t>
+              <a:t>Report</a:t>
             </a:r>
             <a:endParaRPr b="0" i="0" sz="1400" u="none" cap="none" strike="noStrike">
               <a:solidFill>
@@ -25383,7 +25383,7 @@
                 <a:cs typeface="Calibri"/>
                 <a:sym typeface="Calibri"/>
               </a:rPr>
-              <a:t>Challenge the vouch with evidence</a:t>
+              <a:t>Open an author dispute with evidence</a:t>
             </a:r>
             <a:endParaRPr b="0" i="0" sz="1100" u="none" cap="none" strike="noStrike">
               <a:solidFill>
@@ -25581,7 +25581,7 @@
                 <a:cs typeface="Calibri"/>
                 <a:sym typeface="Calibri"/>
               </a:rPr>
-              <a:t>Create a skill listing</a:t>
+              <a:t>Create a USDC-priced skill listing</a:t>
             </a:r>
             <a:endParaRPr b="0" i="0" sz="1100" u="none" cap="none" strike="noStrike">
               <a:solidFill>
@@ -25714,7 +25714,7 @@
                 <a:cs typeface="Consolas"/>
                 <a:sym typeface="Consolas"/>
               </a:rPr>
-              <a:t>Program: ELmVnLSNuwNca4PfPqeqNowoUF8aDdtfto3rF9d89wf</a:t>
+              <a:t>Program: AgNtCcWfeMYUzHxvGdZP5BJszQhx6NJGB4pQ7AN6XVWz</a:t>
             </a:r>
             <a:endParaRPr b="0" i="0" sz="800" u="none" cap="none" strike="noStrike">
               <a:solidFill>
@@ -25951,7 +25951,7 @@
 </file>
 
 <file path=ppt/slides/slide13.xml><?xml version="1.0" encoding="utf-8"?>
-<p:sld xmlns:a="http://schemas.openxmlformats.org/drawingml/2006/main" xmlns:r="http://schemas.openxmlformats.org/officeDocument/2006/relationships" xmlns:mc="http://schemas.openxmlformats.org/markup-compatibility/2006" xmlns:mv="urn:schemas-microsoft-com:mac:vml" xmlns:p="http://schemas.openxmlformats.org/presentationml/2006/main" xmlns:c="http://schemas.openxmlformats.org/drawingml/2006/chart" xmlns:dgm="http://schemas.openxmlformats.org/drawingml/2006/diagram" xmlns:o="urn:schemas-microsoft-com:office:office" xmlns:v="urn:schemas-microsoft-com:vml" xmlns:pvml="urn:schemas-microsoft-com:office:powerpoint" xmlns:com="http://schemas.openxmlformats.org/drawingml/2006/compatibility" xmlns:p14="http://schemas.microsoft.com/office/powerpoint/2010/main" xmlns:p15="http://schemas.microsoft.com/office/powerpoint/2012/main" xmlns:ahyp="http://schemas.microsoft.com/office/drawing/2018/hyperlinkcolor">
+<p:sld xmlns:a="http://schemas.openxmlformats.org/drawingml/2006/main" xmlns:p="http://schemas.openxmlformats.org/presentationml/2006/main" xmlns:r="http://schemas.openxmlformats.org/officeDocument/2006/relationships">
   <p:cSld>
     <p:bg>
       <p:bgPr>
@@ -26280,7 +26280,7 @@
                 <a:cs typeface="Calibri"/>
                 <a:sym typeface="Calibri"/>
               </a:rPr>
-              <a:t>Get free devnet SOL: </a:t>
+              <a:t>Devnet testing still needs SOL for fees/rent; USDC is the protocol capital.</a:t>
             </a:r>
             <a:r>
               <a:rPr b="0" i="0" lang="en" sz="1400" u="sng" cap="none" strike="noStrike">
@@ -26293,7 +26293,7 @@
                 <a:sym typeface="Calibri"/>
                 <a:hlinkClick r:id="rId3"/>
               </a:rPr>
-              <a:t>faucet.solana.com</a:t>
+              <a:t/>
             </a:r>
             <a:r>
               <a:rPr b="0" i="0" lang="en" sz="1400" u="none" cap="none" strike="noStrike">
@@ -26305,7 +26305,7 @@
                 <a:cs typeface="Calibri"/>
                 <a:sym typeface="Calibri"/>
               </a:rPr>
-              <a:t> or just ask me and I’ll send you some</a:t>
+              <a:t/>
             </a:r>
             <a:endParaRPr b="0" i="0" sz="1400" u="none" cap="none" strike="noStrike">
               <a:solidFill>
@@ -26729,7 +26729,7 @@
                 <a:cs typeface="Calibri"/>
                 <a:sym typeface="Calibri"/>
               </a:rPr>
-              <a:t>Feb 2026</a:t>
+              <a:t>May 2026</a:t>
             </a:r>
             <a:endParaRPr b="0" i="0" sz="1400" u="none" cap="none" strike="noStrike">
               <a:solidFill>
@@ -26942,7 +26942,7 @@
 </file>
 
 <file path=ppt/slides/slide14.xml><?xml version="1.0" encoding="utf-8"?>
-<p:sld xmlns:a="http://schemas.openxmlformats.org/drawingml/2006/main" xmlns:r="http://schemas.openxmlformats.org/officeDocument/2006/relationships" xmlns:mc="http://schemas.openxmlformats.org/markup-compatibility/2006" xmlns:mv="urn:schemas-microsoft-com:mac:vml" xmlns:p="http://schemas.openxmlformats.org/presentationml/2006/main" xmlns:c="http://schemas.openxmlformats.org/drawingml/2006/chart" xmlns:dgm="http://schemas.openxmlformats.org/drawingml/2006/diagram" xmlns:o="urn:schemas-microsoft-com:office:office" xmlns:v="urn:schemas-microsoft-com:vml" xmlns:pvml="urn:schemas-microsoft-com:office:powerpoint" xmlns:com="http://schemas.openxmlformats.org/drawingml/2006/compatibility" xmlns:p14="http://schemas.microsoft.com/office/powerpoint/2010/main" xmlns:p15="http://schemas.microsoft.com/office/powerpoint/2012/main" xmlns:ahyp="http://schemas.microsoft.com/office/drawing/2018/hyperlinkcolor">
+<p:sld xmlns:a="http://schemas.openxmlformats.org/drawingml/2006/main" xmlns:p="http://schemas.openxmlformats.org/presentationml/2006/main">
   <p:cSld>
     <p:bg>
       <p:bgPr>
@@ -27210,7 +27210,7 @@
                 <a:cs typeface="Inconsolata"/>
                 <a:sym typeface="Inconsolata"/>
               </a:rPr>
-              <a:t>8 On-Chain Accounts</a:t>
+              <a:t>9 Anchor Account Structs</a:t>
             </a:r>
             <a:endParaRPr b="0" i="0" sz="1600" u="none" cap="none" strike="noStrike">
               <a:solidFill>
@@ -27401,7 +27401,7 @@
                 <a:cs typeface="Calibri"/>
                 <a:sym typeface="Calibri"/>
               </a:rPr>
-              <a:t>Global params (min stake, bond floor, weights)</a:t>
+              <a:t>Global params (USDC mint, floors, authorities)</a:t>
             </a:r>
             <a:endParaRPr b="0" i="0" sz="1000" u="none" cap="none" strike="noStrike">
               <a:solidFill>
@@ -27717,7 +27717,7 @@
                 <a:cs typeface="Consolas"/>
                 <a:sym typeface="Consolas"/>
               </a:rPr>
-              <a:t>Vouch</a:t>
+              <a:t>AuthorBond / Vouch</a:t>
             </a:r>
             <a:endParaRPr b="0" i="0" sz="1100" u="none" cap="none" strike="noStrike">
               <a:solidFill>
@@ -27783,7 +27783,7 @@
                 <a:cs typeface="Calibri"/>
                 <a:sym typeface="Calibri"/>
               </a:rPr>
-              <a:t>Stake-backed endorsement</a:t>
+              <a:t>USDC-backed self-stake and endorsements</a:t>
             </a:r>
             <a:endParaRPr b="0" i="0" sz="1000" u="none" cap="none" strike="noStrike">
               <a:solidFill>
@@ -27908,7 +27908,7 @@
                 <a:cs typeface="Consolas"/>
                 <a:sym typeface="Consolas"/>
               </a:rPr>
-              <a:t>AuthorDispute</a:t>
+              <a:t>AuthorDispute / VouchLink</a:t>
             </a:r>
             <a:endParaRPr b="0" i="0" sz="1100" u="none" cap="none" strike="noStrike">
               <a:solidFill>
@@ -27974,7 +27974,7 @@
                 <a:cs typeface="Calibri"/>
                 <a:sym typeface="Calibri"/>
               </a:rPr>
-              <a:t>Author-scoped dispute + evidence</a:t>
+              <a:t>Skill-scoped dispute + backing snapshot</a:t>
             </a:r>
             <a:endParaRPr b="0" i="0" sz="1000" u="none" cap="none" strike="noStrike">
               <a:solidFill>
@@ -28099,7 +28099,7 @@
                 <a:cs typeface="Consolas"/>
                 <a:sym typeface="Consolas"/>
               </a:rPr>
-              <a:t>SkillListing</a:t>
+              <a:t>SkillListing / ListingVouchPosition</a:t>
             </a:r>
             <a:endParaRPr b="0" i="0" sz="1100" u="none" cap="none" strike="noStrike">
               <a:solidFill>
@@ -28165,7 +28165,7 @@
                 <a:cs typeface="Calibri"/>
                 <a:sym typeface="Calibri"/>
               </a:rPr>
-              <a:t>Published skill + revenue tracking</a:t>
+              <a:t>Published skill + voucher reward accounting</a:t>
             </a:r>
             <a:endParaRPr b="0" i="0" sz="1000" u="none" cap="none" strike="noStrike">
               <a:solidFill>
@@ -28422,7 +28422,7 @@
                 <a:cs typeface="Inconsolata"/>
                 <a:sym typeface="Inconsolata"/>
               </a:rPr>
-              <a:t>15 Instructions</a:t>
+              <a:t>16 Instructions</a:t>
             </a:r>
             <a:endParaRPr b="0" i="0" sz="1600" u="none" cap="none" strike="noStrike">
               <a:solidFill>
@@ -29422,7 +29422,7 @@
                 <a:cs typeface="Consolas"/>
                 <a:sym typeface="Consolas"/>
               </a:rPr>
-              <a:t>deposit/withdraw_author_bond</a:t>
+              <a:t>author_bond + listing lifecycle</a:t>
             </a:r>
             <a:endParaRPr b="0" i="0" sz="1000" u="none" cap="none" strike="noStrike">
               <a:solidFill>
@@ -29672,7 +29672,7 @@
                 <a:cs typeface="Consolas"/>
                 <a:sym typeface="Consolas"/>
               </a:rPr>
-              <a:t>claim_voucher_revenue</a:t>
+              <a:t>claim/link/unlink rewards</a:t>
             </a:r>
             <a:endParaRPr b="0" i="0" sz="1000" u="none" cap="none" strike="noStrike">
               <a:solidFill>
@@ -29952,7 +29952,7 @@
 </file>
 
 <file path=ppt/slides/slide15.xml><?xml version="1.0" encoding="utf-8"?>
-<p:sld xmlns:a="http://schemas.openxmlformats.org/drawingml/2006/main" xmlns:r="http://schemas.openxmlformats.org/officeDocument/2006/relationships" xmlns:mc="http://schemas.openxmlformats.org/markup-compatibility/2006" xmlns:mv="urn:schemas-microsoft-com:mac:vml" xmlns:p="http://schemas.openxmlformats.org/presentationml/2006/main" xmlns:c="http://schemas.openxmlformats.org/drawingml/2006/chart" xmlns:dgm="http://schemas.openxmlformats.org/drawingml/2006/diagram" xmlns:o="urn:schemas-microsoft-com:office:office" xmlns:v="urn:schemas-microsoft-com:vml" xmlns:pvml="urn:schemas-microsoft-com:office:powerpoint" xmlns:com="http://schemas.openxmlformats.org/drawingml/2006/compatibility" xmlns:p14="http://schemas.microsoft.com/office/powerpoint/2010/main" xmlns:p15="http://schemas.microsoft.com/office/powerpoint/2012/main" xmlns:ahyp="http://schemas.microsoft.com/office/drawing/2018/hyperlinkcolor">
+<p:sld xmlns:a="http://schemas.openxmlformats.org/drawingml/2006/main" xmlns:p="http://schemas.openxmlformats.org/presentationml/2006/main" xmlns:r="http://schemas.openxmlformats.org/officeDocument/2006/relationships">
   <p:cSld>
     <p:bg>
       <p:bgPr>
@@ -31126,7 +31126,7 @@
                   <a:cs typeface="Inconsolata"/>
                   <a:sym typeface="Inconsolata"/>
                 </a:rPr>
-                <a:t>File a Claim</a:t>
+                <a:t>Report</a:t>
               </a:r>
               <a:endParaRPr b="0" i="0" sz="1600" u="none" cap="none" strike="noStrike">
                 <a:solidFill>
@@ -31192,7 +31192,7 @@
                   <a:cs typeface="Calibri"/>
                   <a:sym typeface="Calibri"/>
                 </a:rPr>
-                <a:t>Anyone can challenge a skill with evidence</a:t>
+                <a:t>Anyone can report a skill with evidence</a:t>
               </a:r>
               <a:endParaRPr b="0" i="0" sz="1100" u="none" cap="none" strike="noStrike">
                 <a:solidFill>
@@ -31972,7 +31972,7 @@
                   <a:cs typeface="Calibri"/>
                   <a:sym typeface="Calibri"/>
                 </a:rPr>
-                <a:t>Admin resolves disputes today; slashing and payouts settled on-chain</a:t>
+                <a:t>Authorized resolver handles disputes today; slashing and payouts settle on-chain</a:t>
               </a:r>
               <a:endParaRPr b="0" i="0" sz="1100" u="none" cap="none" strike="noStrike">
                 <a:solidFill>
@@ -32266,7 +32266,7 @@
                 <a:cs typeface="Calibri"/>
                 <a:sym typeface="Calibri"/>
               </a:rPr>
-              <a:t>Agent installs skill</a:t>
+              <a:t>Agent installs skill or signs for paid raw download access</a:t>
             </a:r>
             <a:endParaRPr b="0" i="0" sz="1100" u="none" cap="none" strike="noStrike">
               <a:solidFill>
@@ -32343,7 +32343,7 @@
 </file>
 
 <file path=ppt/slides/slide16.xml><?xml version="1.0" encoding="utf-8"?>
-<p:sld xmlns:a="http://schemas.openxmlformats.org/drawingml/2006/main" xmlns:r="http://schemas.openxmlformats.org/officeDocument/2006/relationships" xmlns:mc="http://schemas.openxmlformats.org/markup-compatibility/2006" xmlns:mv="urn:schemas-microsoft-com:mac:vml" xmlns:p="http://schemas.openxmlformats.org/presentationml/2006/main" xmlns:c="http://schemas.openxmlformats.org/drawingml/2006/chart" xmlns:dgm="http://schemas.openxmlformats.org/drawingml/2006/diagram" xmlns:o="urn:schemas-microsoft-com:office:office" xmlns:v="urn:schemas-microsoft-com:vml" xmlns:pvml="urn:schemas-microsoft-com:office:powerpoint" xmlns:com="http://schemas.openxmlformats.org/drawingml/2006/compatibility" xmlns:p14="http://schemas.microsoft.com/office/powerpoint/2010/main" xmlns:p15="http://schemas.microsoft.com/office/powerpoint/2012/main" xmlns:ahyp="http://schemas.microsoft.com/office/drawing/2018/hyperlinkcolor">
+<p:sld xmlns:a="http://schemas.openxmlformats.org/drawingml/2006/main" xmlns:p="http://schemas.openxmlformats.org/presentationml/2006/main" xmlns:r="http://schemas.openxmlformats.org/officeDocument/2006/relationships">
   <p:cSld>
     <p:bg>
       <p:bgPr>
@@ -32897,7 +32897,7 @@
                 <a:cs typeface="Calibri"/>
                 <a:sym typeface="Calibri"/>
               </a:rPr>
-              <a:t>What makes a skill trusted? No binary threshold yet. Proposal: 3+ vouchers, 1+ SOL staked, 0 disputes.</a:t>
+              <a:t>What makes a skill trusted? No binary threshold yet. Proposal: multiple vouchers, meaningful USDC backing, clean dispute record.</a:t>
             </a:r>
             <a:endParaRPr b="0" i="0" sz="1100" u="none" cap="none" strike="noStrike">
               <a:solidFill>
@@ -33802,7 +33802,7 @@
                 <a:cs typeface="Calibri"/>
                 <a:sym typeface="Calibri"/>
               </a:rPr>
-              <a:t>Who resolves disputes at scale? Today: program authority only. Options: multi-sig, DAO, stake-weighted voting.</a:t>
+              <a:t>Who resolves disputes at scale? Today: authorized resolver. Mainnet options: multi-sig, DAO, stake-weighted voting.</a:t>
             </a:r>
             <a:endParaRPr b="0" i="0" sz="1200" u="none" cap="none" strike="noStrike">
               <a:solidFill>
@@ -34698,7 +34698,7 @@
 </file>
 
 <file path=ppt/slides/slide17.xml><?xml version="1.0" encoding="utf-8"?>
-<p:sld xmlns:a="http://schemas.openxmlformats.org/drawingml/2006/main" xmlns:r="http://schemas.openxmlformats.org/officeDocument/2006/relationships" xmlns:mc="http://schemas.openxmlformats.org/markup-compatibility/2006" xmlns:mv="urn:schemas-microsoft-com:mac:vml" xmlns:p="http://schemas.openxmlformats.org/presentationml/2006/main" xmlns:c="http://schemas.openxmlformats.org/drawingml/2006/chart" xmlns:dgm="http://schemas.openxmlformats.org/drawingml/2006/diagram" xmlns:o="urn:schemas-microsoft-com:office:office" xmlns:v="urn:schemas-microsoft-com:vml" xmlns:pvml="urn:schemas-microsoft-com:office:powerpoint" xmlns:com="http://schemas.openxmlformats.org/drawingml/2006/compatibility" xmlns:p14="http://schemas.microsoft.com/office/powerpoint/2010/main" xmlns:p15="http://schemas.microsoft.com/office/powerpoint/2012/main" xmlns:ahyp="http://schemas.microsoft.com/office/drawing/2018/hyperlinkcolor">
+<p:sld xmlns:a="http://schemas.openxmlformats.org/drawingml/2006/main" xmlns:p="http://schemas.openxmlformats.org/presentationml/2006/main" xmlns:r="http://schemas.openxmlformats.org/officeDocument/2006/relationships">
   <p:cSld>
     <p:bg>
       <p:bgPr>
@@ -35252,7 +35252,7 @@
                 <a:cs typeface="Calibri"/>
                 <a:sym typeface="Calibri"/>
               </a:rPr>
-              <a:t>What makes a skill trusted? No binary threshold yet. Proposal: 3+ vouchers, 1+ SOL staked, 0 disputes.</a:t>
+              <a:t>What makes a skill trusted? No binary threshold yet. Proposal: multiple vouchers, meaningful USDC backing, clean dispute record.</a:t>
             </a:r>
             <a:endParaRPr b="0" i="0" sz="1100" u="none" cap="none" strike="noStrike">
               <a:solidFill>
@@ -36157,7 +36157,7 @@
                 <a:cs typeface="Calibri"/>
                 <a:sym typeface="Calibri"/>
               </a:rPr>
-              <a:t>Who resolves disputes at scale? Today: program authority only. Options: multi-sig, DAO, stake-weighted voting.</a:t>
+              <a:t>Who resolves disputes at scale? Today: authorized resolver. Mainnet options: multi-sig, DAO, stake-weighted voting.</a:t>
             </a:r>
             <a:endParaRPr b="0" i="0" sz="1200" u="none" cap="none" strike="noStrike">
               <a:solidFill>
@@ -42075,7 +42075,7 @@
 </file>
 
 <file path=ppt/slides/slide6.xml><?xml version="1.0" encoding="utf-8"?>
-<p:sld xmlns:a="http://schemas.openxmlformats.org/drawingml/2006/main" xmlns:r="http://schemas.openxmlformats.org/officeDocument/2006/relationships" xmlns:mc="http://schemas.openxmlformats.org/markup-compatibility/2006" xmlns:mv="urn:schemas-microsoft-com:mac:vml" xmlns:p="http://schemas.openxmlformats.org/presentationml/2006/main" xmlns:c="http://schemas.openxmlformats.org/drawingml/2006/chart" xmlns:dgm="http://schemas.openxmlformats.org/drawingml/2006/diagram" xmlns:o="urn:schemas-microsoft-com:office:office" xmlns:v="urn:schemas-microsoft-com:vml" xmlns:pvml="urn:schemas-microsoft-com:office:powerpoint" xmlns:com="http://schemas.openxmlformats.org/drawingml/2006/compatibility" xmlns:p14="http://schemas.microsoft.com/office/powerpoint/2010/main" xmlns:p15="http://schemas.microsoft.com/office/powerpoint/2012/main" xmlns:ahyp="http://schemas.microsoft.com/office/drawing/2018/hyperlinkcolor">
+<p:sld xmlns:a="http://schemas.openxmlformats.org/drawingml/2006/main" xmlns:p="http://schemas.openxmlformats.org/presentationml/2006/main" xmlns:r="http://schemas.openxmlformats.org/officeDocument/2006/relationships">
   <p:cSld>
     <p:bg>
       <p:bgPr>
@@ -42667,7 +42667,7 @@
                 <a:cs typeface="Calibri"/>
                 <a:sym typeface="Calibri"/>
               </a:rPr>
-              <a:t>Agents and Users stake SOL to vouch for Skill Authors. Real economic alignment.</a:t>
+              <a:t>Agents and users stake USDC to vouch for Skill Authors. Real economic alignment.</a:t>
             </a:r>
             <a:endParaRPr b="0" i="0" sz="1200" u="none" cap="none" strike="noStrike">
               <a:solidFill>
@@ -43366,7 +43366,7 @@
                 <a:cs typeface="Calibri"/>
                 <a:sym typeface="Calibri"/>
               </a:rPr>
-              <a:t>15 </a:t>
+              <a:t>16</a:t>
             </a:r>
             <a:r>
               <a:rPr b="0" i="0" lang="en" sz="1100" u="none" cap="none" strike="noStrike">
@@ -43390,7 +43390,7 @@
                 <a:cs typeface="Calibri"/>
                 <a:sym typeface="Calibri"/>
               </a:rPr>
-              <a:t>8</a:t>
+              <a:t>9</a:t>
             </a:r>
             <a:r>
               <a:rPr b="0" i="0" lang="en" sz="1100" u="none" cap="none" strike="noStrike">
@@ -43402,7 +43402,7 @@
                 <a:cs typeface="Calibri"/>
                 <a:sym typeface="Calibri"/>
               </a:rPr>
-              <a:t> account types</a:t>
+              <a:t> account structs</a:t>
             </a:r>
             <a:endParaRPr b="0" i="0" sz="1100" u="none" cap="none" strike="noStrike">
               <a:solidFill>
@@ -43584,7 +43584,7 @@
 </file>
 
 <file path=ppt/slides/slide7.xml><?xml version="1.0" encoding="utf-8"?>
-<p:sld xmlns:a="http://schemas.openxmlformats.org/drawingml/2006/main" xmlns:r="http://schemas.openxmlformats.org/officeDocument/2006/relationships" xmlns:mc="http://schemas.openxmlformats.org/markup-compatibility/2006" xmlns:mv="urn:schemas-microsoft-com:mac:vml" xmlns:p="http://schemas.openxmlformats.org/presentationml/2006/main" xmlns:c="http://schemas.openxmlformats.org/drawingml/2006/chart" xmlns:dgm="http://schemas.openxmlformats.org/drawingml/2006/diagram" xmlns:o="urn:schemas-microsoft-com:office:office" xmlns:v="urn:schemas-microsoft-com:vml" xmlns:pvml="urn:schemas-microsoft-com:office:powerpoint" xmlns:com="http://schemas.openxmlformats.org/drawingml/2006/compatibility" xmlns:p14="http://schemas.microsoft.com/office/powerpoint/2010/main" xmlns:p15="http://schemas.microsoft.com/office/powerpoint/2012/main" xmlns:ahyp="http://schemas.microsoft.com/office/drawing/2018/hyperlinkcolor">
+<p:sld xmlns:a="http://schemas.openxmlformats.org/drawingml/2006/main" xmlns:p="http://schemas.openxmlformats.org/presentationml/2006/main" xmlns:r="http://schemas.openxmlformats.org/officeDocument/2006/relationships">
   <p:cSld>
     <p:bg>
       <p:bgPr>
@@ -44404,7 +44404,7 @@
                 <a:cs typeface="Calibri"/>
                 <a:sym typeface="Calibri"/>
               </a:rPr>
-              <a:t>Purchase a skill:</a:t>
+              <a:t>Purchase a paid skill in USDC, or install a free skill backed by AuthorBond first-loss capital.</a:t>
             </a:r>
             <a:endParaRPr b="0" i="0" sz="1100" u="none" cap="none" strike="noStrike">
               <a:solidFill>
@@ -44444,7 +44444,7 @@
                 <a:cs typeface="Calibri"/>
                 <a:sym typeface="Calibri"/>
               </a:rPr>
-              <a:t>Authors and Vouchers put money on the line to ensure clean skills</a:t>
+              <a:t>Authors and vouchers put USDC at risk to back quality skills.</a:t>
             </a:r>
             <a:endParaRPr b="0" i="0" sz="1100" u="none" cap="none" strike="noStrike">
               <a:solidFill>
@@ -45123,7 +45123,7 @@
                 <a:cs typeface="Calibri"/>
                 <a:sym typeface="Calibri"/>
               </a:rPr>
-              <a:t>Agent installs skill.  Skill updates are included in the purchase</a:t>
+              <a:t>Agent installs skill. Paid raw downloads use purchase proof plus signed access.</a:t>
             </a:r>
             <a:endParaRPr b="0" i="0" sz="1100" u="none" cap="none" strike="noStrike">
               <a:solidFill>
@@ -45579,7 +45579,7 @@
 </file>
 
 <file path=ppt/slides/slide8.xml><?xml version="1.0" encoding="utf-8"?>
-<p:sld xmlns:a="http://schemas.openxmlformats.org/drawingml/2006/main" xmlns:r="http://schemas.openxmlformats.org/officeDocument/2006/relationships" xmlns:mc="http://schemas.openxmlformats.org/markup-compatibility/2006" xmlns:mv="urn:schemas-microsoft-com:mac:vml" xmlns:p="http://schemas.openxmlformats.org/presentationml/2006/main" xmlns:c="http://schemas.openxmlformats.org/drawingml/2006/chart" xmlns:dgm="http://schemas.openxmlformats.org/drawingml/2006/diagram" xmlns:o="urn:schemas-microsoft-com:office:office" xmlns:v="urn:schemas-microsoft-com:vml" xmlns:pvml="urn:schemas-microsoft-com:office:powerpoint" xmlns:com="http://schemas.openxmlformats.org/drawingml/2006/compatibility" xmlns:p14="http://schemas.microsoft.com/office/powerpoint/2010/main" xmlns:p15="http://schemas.microsoft.com/office/powerpoint/2012/main" xmlns:ahyp="http://schemas.microsoft.com/office/drawing/2018/hyperlinkcolor">
+<p:sld xmlns:a="http://schemas.openxmlformats.org/drawingml/2006/main" xmlns:p="http://schemas.openxmlformats.org/presentationml/2006/main">
   <p:cSld>
     <p:bg>
       <p:bgPr>
@@ -45847,7 +45847,7 @@
                 <a:cs typeface="Calibri"/>
                 <a:sym typeface="Calibri"/>
               </a:rPr>
-              <a:t>A revenue model that rewards honest vouching</a:t>
+              <a:t>A USDC revenue model that rewards honest vouching</a:t>
             </a:r>
             <a:endParaRPr b="0" i="0" sz="1400" u="none" cap="none" strike="noStrike">
               <a:solidFill>
@@ -46104,7 +46104,7 @@
                 <a:cs typeface="Calibri"/>
                 <a:sym typeface="Calibri"/>
               </a:rPr>
-              <a:t>Immediate payment on every purchase. Creates incentive to build quality skills.</a:t>
+              <a:t>Direct author payment today; withdrawable proceeds escrow is Milestone 13 WIP.</a:t>
             </a:r>
             <a:endParaRPr b="0" i="0" sz="1200" u="none" cap="none" strike="noStrike">
               <a:solidFill>
@@ -46361,7 +46361,7 @@
                 <a:cs typeface="Calibri"/>
                 <a:sym typeface="Calibri"/>
               </a:rPr>
-              <a:t>Distributed proportionally to stake. Passive income for trustworthy vouchers.</a:t>
+              <a:t>Distributed proportionally to linked vouch stake. Passive income for trustworthy vouchers.</a:t>
             </a:r>
             <a:endParaRPr b="0" i="0" sz="1200" u="none" cap="none" strike="noStrike">
               <a:solidFill>
@@ -47308,7 +47308,7 @@
 </file>
 
 <file path=ppt/slides/slide9.xml><?xml version="1.0" encoding="utf-8"?>
-<p:sld xmlns:a="http://schemas.openxmlformats.org/drawingml/2006/main" xmlns:r="http://schemas.openxmlformats.org/officeDocument/2006/relationships" xmlns:mc="http://schemas.openxmlformats.org/markup-compatibility/2006" xmlns:mv="urn:schemas-microsoft-com:mac:vml" xmlns:p="http://schemas.openxmlformats.org/presentationml/2006/main" xmlns:c="http://schemas.openxmlformats.org/drawingml/2006/chart" xmlns:dgm="http://schemas.openxmlformats.org/drawingml/2006/diagram" xmlns:o="urn:schemas-microsoft-com:office:office" xmlns:v="urn:schemas-microsoft-com:vml" xmlns:pvml="urn:schemas-microsoft-com:office:powerpoint" xmlns:com="http://schemas.openxmlformats.org/drawingml/2006/compatibility" xmlns:p14="http://schemas.microsoft.com/office/powerpoint/2010/main" xmlns:p15="http://schemas.microsoft.com/office/powerpoint/2012/main" xmlns:ahyp="http://schemas.microsoft.com/office/drawing/2018/hyperlinkcolor">
+<p:sld xmlns:a="http://schemas.openxmlformats.org/drawingml/2006/main" xmlns:p="http://schemas.openxmlformats.org/presentationml/2006/main" xmlns:r="http://schemas.openxmlformats.org/officeDocument/2006/relationships">
   <p:cSld>
     <p:bg>
       <p:bgPr>
@@ -47576,7 +47576,7 @@
                 <a:cs typeface="Calibri"/>
                 <a:sym typeface="Calibri"/>
               </a:rPr>
-              <a:t>Agents can buy listed skills on-chain natively, no human checkout needed</a:t>
+              <a:t>Agents buy listed skills on-chain with USDC, no human checkout needed</a:t>
             </a:r>
             <a:endParaRPr b="0" i="0" sz="1300" u="none" cap="none" strike="noStrike">
               <a:solidFill>
@@ -48340,7 +48340,7 @@
                 <a:cs typeface="Consolas"/>
                 <a:sym typeface="Consolas"/>
               </a:rPr>
-              <a:t>PaymentRequirement</a:t>
+              <a:t>Direct purchase required</a:t>
             </a:r>
             <a:endParaRPr b="0" i="0" sz="700" u="none" cap="none" strike="noStrike">
               <a:solidFill>
@@ -48380,7 +48380,7 @@
                 <a:cs typeface="Consolas"/>
                 <a:sym typeface="Consolas"/>
               </a:rPr>
-              <a:t>{recipient, amount}</a:t>
+              <a:t>{price_usdc_micros, listing}</a:t>
             </a:r>
             <a:endParaRPr b="0" i="0" sz="700" u="none" cap="none" strike="noStrike">
               <a:solidFill>
@@ -48771,7 +48771,7 @@
                 <a:cs typeface="Consolas"/>
                 <a:sym typeface="Consolas"/>
               </a:rPr>
-              <a:t>purchaseSkill tx</a:t>
+              <a:t>purchase_skill tx</a:t>
             </a:r>
             <a:endParaRPr b="0" i="0" sz="700" u="none" cap="none" strike="noStrike">
               <a:solidFill>
@@ -49193,7 +49193,7 @@
                 <a:cs typeface="Consolas"/>
                 <a:sym typeface="Consolas"/>
               </a:rPr>
-              <a:t>X-Payment-Proof header</a:t>
+              <a:t>X-AgentVouch-Auth header</a:t>
             </a:r>
             <a:endParaRPr b="0" i="0" sz="700" u="none" cap="none" strike="noStrike">
               <a:solidFill>
@@ -49233,7 +49233,7 @@
                 <a:cs typeface="Consolas"/>
                 <a:sym typeface="Consolas"/>
               </a:rPr>
-              <a:t>(buyer, txSig)</a:t>
+              <a:t>(buyer, listing, timestamp)</a:t>
             </a:r>
             <a:endParaRPr b="0" i="0" sz="700" u="none" cap="none" strike="noStrike">
               <a:solidFill>
@@ -49807,7 +49807,7 @@
                 <a:cs typeface="Inconsolata"/>
                 <a:sym typeface="Inconsolata"/>
               </a:rPr>
-              <a:t>For listed paid skills, the raw endpoint can require an on-chain purchase.</a:t>
+              <a:t>For protocol-listed paid skills, the raw endpoint requires a verified on-chain purchase.</a:t>
             </a:r>
             <a:endParaRPr b="0" i="0" sz="1400" u="none" cap="none" strike="noStrike">
               <a:solidFill>
@@ -50370,7 +50370,7 @@
                 <a:cs typeface="Consolas"/>
                 <a:sym typeface="Consolas"/>
               </a:rPr>
-              <a:t>Yes. The buyer agent needs a funded Solana wallet. Just ask your agent to create a Solana wallet and send it funds.</a:t>
+              <a:t>Yes. The buyer agent needs USDC for purchases and a small amount of SOL for rent and fees.</a:t>
             </a:r>
             <a:endParaRPr b="0" i="0" sz="700" u="none" cap="none" strike="noStrike">
               <a:solidFill>
@@ -50720,7 +50720,7 @@
                 <a:cs typeface="Consolas"/>
                 <a:sym typeface="Consolas"/>
               </a:rPr>
-              <a:t>Not today. This version uses wallet funding, not fiat rails</a:t>
+              <a:t>Not today. This version uses wallet funding and USDC settlement, not fiat rails.</a:t>
             </a:r>
             <a:endParaRPr b="0" i="0" sz="700" u="none" cap="none" strike="noStrike">
               <a:solidFill>

</xml_diff>